<commit_message>
Odkazy uvnitr materialu srovnany s nazvy na webu
Balicky odkazovaly samy na sebe puvodnimi nazvy (01_PRO_UCITELE/
AI_plany_hodin_a_metodika.docx), jenze na webu se soubory jmenuji
cesky. Ucitel by podle metodiky hledal soubor, ktery neexistuje.

- prepsano 26 souboru: nazvy slozek, nazvy souboru i vety typu
  "ve slozce 03" -> "ve slozce Podklady k aktivitam"
- u .docx/.pptx se menil jen text v XML castech, zbytek zipu zustal
  bit po bitu stejny; overena celistvost vsech 26 archivu
- "Prijmeni_Jmeno_Internet_bezpecnost.docx" ponechano - to neni odkaz
  na soubor, ale pokyn, jak si ma zak pojmenovat vlastni kopii

Odznak publika oznacuje vyjimku, ne vychozi stav:
- "zaci" viselo na vsem mimo ucitelskou slozku, tedy i na pruvodci
  pro ucitele. Vychozi publikum je ted "both" a odznak se ukazuje
  jen u slozek "Pro ucitele" / "Pro zaky".
- z licencniho souboru odstranena veta "Tyto soubory dodal uzivatel
  jako overeny zdroj"

Co-Authored-By: Claude Opus 4.8 <noreply@anthropic.com>
</commit_message>
<xml_diff>
--- a/public/materialy/1L/10/Prezentace k hodinám/1. Základy AI a učení z dat.pptx
+++ b/public/materialy/1L/10/Prezentace k hodinám/1. Základy AI a učení z dat.pptx
@@ -548,7 +548,7 @@
           </a:p>
           <a:p xmlns:a="http://schemas.openxmlformats.org/drawingml/2006/main">
             <a:r>
-              <a:t>Podklady: 01_laborator_fungovani_AI.html, 01_trenovaci_data.csv</a:t>
+              <a:t>Podklady: 1. Laboratoř fungování AI.html, 1. Trénovací data.csv</a:t>
             </a:r>
           </a:p>
           <a:p xmlns:a="http://schemas.openxmlformats.org/drawingml/2006/main">
@@ -578,7 +578,7 @@
           </a:p>
           <a:p xmlns:a="http://schemas.openxmlformats.org/drawingml/2006/main">
             <a:r>
-              <a:t>AI_Fluency__Key_Terminology_Cheat_Sheet.pdf</a:t>
+              <a:t>AI_Fluency_Key_Terminology_Cheat_Sheet.pdf</a:t>
             </a:r>
           </a:p>
           <a:p xmlns:a="http://schemas.openxmlformats.org/drawingml/2006/main">
@@ -698,7 +698,7 @@
           </a:p>
           <a:p xmlns:a="http://schemas.openxmlformats.org/drawingml/2006/main">
             <a:r>
-              <a:t>AI_Fluency__Key_Terminology_Cheat_Sheet.pdf</a:t>
+              <a:t>AI_Fluency_Key_Terminology_Cheat_Sheet.pdf</a:t>
             </a:r>
           </a:p>
           <a:p xmlns:a="http://schemas.openxmlformats.org/drawingml/2006/main">
@@ -818,7 +818,7 @@
           </a:p>
           <a:p xmlns:a="http://schemas.openxmlformats.org/drawingml/2006/main">
             <a:r>
-              <a:t>AI_Fluency__Key_Terminology_Cheat_Sheet.pdf</a:t>
+              <a:t>AI_Fluency_Key_Terminology_Cheat_Sheet.pdf</a:t>
             </a:r>
           </a:p>
           <a:p xmlns:a="http://schemas.openxmlformats.org/drawingml/2006/main">
@@ -903,7 +903,7 @@
           <a:lstStyle xmlns:a="http://schemas.openxmlformats.org/drawingml/2006/main"/>
           <a:p xmlns:a="http://schemas.openxmlformats.org/drawingml/2006/main">
             <a:r>
-              <a:t>Podklady: 01_laborator_fungovani_AI.html, 01_trenovaci_data.csv</a:t>
+              <a:t>Podklady: 1. Laboratoř fungování AI.html, 1. Trénovací data.csv</a:t>
             </a:r>
           </a:p>
           <a:p xmlns:a="http://schemas.openxmlformats.org/drawingml/2006/main">
@@ -913,7 +913,7 @@
           </a:p>
           <a:p xmlns:a="http://schemas.openxmlformats.org/drawingml/2006/main">
             <a:r>
-              <a:t>2. Otevři 01_trenovaci_data.csv a označ příklady, které model při trénování viděl.</a:t>
+              <a:t>2. Otevři 1. Trénovací data.csv a označ příklady, které model při trénování viděl.</a:t>
             </a:r>
           </a:p>
           <a:p xmlns:a="http://schemas.openxmlformats.org/drawingml/2006/main">
@@ -953,7 +953,7 @@
           </a:p>
           <a:p xmlns:a="http://schemas.openxmlformats.org/drawingml/2006/main">
             <a:r>
-              <a:t>AI_Fluency__Key_Terminology_Cheat_Sheet.pdf</a:t>
+              <a:t>AI_Fluency_Key_Terminology_Cheat_Sheet.pdf</a:t>
             </a:r>
           </a:p>
           <a:p xmlns:a="http://schemas.openxmlformats.org/drawingml/2006/main">
@@ -1078,7 +1078,7 @@
           </a:p>
           <a:p xmlns:a="http://schemas.openxmlformats.org/drawingml/2006/main">
             <a:r>
-              <a:t>AI_Fluency__Key_Terminology_Cheat_Sheet.pdf</a:t>
+              <a:t>AI_Fluency_Key_Terminology_Cheat_Sheet.pdf</a:t>
             </a:r>
           </a:p>
           <a:p xmlns:a="http://schemas.openxmlformats.org/drawingml/2006/main">
@@ -1193,7 +1193,7 @@
           </a:p>
           <a:p xmlns:a="http://schemas.openxmlformats.org/drawingml/2006/main">
             <a:r>
-              <a:t>AI_Fluency__Key_Terminology_Cheat_Sheet.pdf</a:t>
+              <a:t>AI_Fluency_Key_Terminology_Cheat_Sheet.pdf</a:t>
             </a:r>
           </a:p>
           <a:p xmlns:a="http://schemas.openxmlformats.org/drawingml/2006/main">
@@ -1308,7 +1308,7 @@
           </a:p>
           <a:p xmlns:a="http://schemas.openxmlformats.org/drawingml/2006/main">
             <a:r>
-              <a:t>AI_Fluency__Key_Terminology_Cheat_Sheet.pdf</a:t>
+              <a:t>AI_Fluency_Key_Terminology_Cheat_Sheet.pdf</a:t>
             </a:r>
           </a:p>
           <a:p xmlns:a="http://schemas.openxmlformats.org/drawingml/2006/main">
@@ -4040,7 +4040,7 @@
               </a:defRPr>
             </a:pPr>
             <a:r>
-              <a:t>01_laborator_fungovani_AI.html · 01_trenovaci_data.csv</a:t>
+              <a:t>1. Laboratoř fungování AI.html · 1. Trénovací data.csv</a:t>
             </a:r>
           </a:p>
         </p:txBody>
@@ -4286,7 +4286,7 @@
               </a:defRPr>
             </a:pPr>
             <a:r>
-              <a:t>Otevři 01_trenovaci_data.csv a označ příklady, které model při trénování viděl.</a:t>
+              <a:t>Otevři 1. Trénovací data.csv a označ příklady, které model při trénování viděl.</a:t>
             </a:r>
           </a:p>
         </p:txBody>

</xml_diff>